<commit_message>
Add standalone Windows export and player download instructions
</commit_message>
<xml_diff>
--- a/docs/presentation/HiddenWatts-Prototype-I.pptx
+++ b/docs/presentation/HiddenWatts-Prototype-I.pptx
@@ -2,20 +2,20 @@
 <file path=ppt/presentation.xml><?xml version="1.0" encoding="utf-8"?>
 <p:presentation xmlns:p="http://schemas.openxmlformats.org/presentationml/2006/main">
   <p:sldMasterIdLst>
-    <p:sldMasterId xmlns:r="http://schemas.openxmlformats.org/officeDocument/2006/relationships" id="2147483648" r:id="Rc9cc17dede8747a2"/>
+    <p:sldMasterId xmlns:r="http://schemas.openxmlformats.org/officeDocument/2006/relationships" id="2147483648" r:id="Rbeb8658c207b406c"/>
   </p:sldMasterIdLst>
   <p:notesMasterIdLst>
-    <p:notesMasterId xmlns:r="http://schemas.openxmlformats.org/officeDocument/2006/relationships" r:id="Rc47d0716387c4fb9"/>
+    <p:notesMasterId xmlns:r="http://schemas.openxmlformats.org/officeDocument/2006/relationships" r:id="R71403d4320714e09"/>
   </p:notesMasterIdLst>
   <p:sldIdLst>
-    <p:sldId xmlns:r="http://schemas.openxmlformats.org/officeDocument/2006/relationships" id="256" r:id="R69e08d02a9024acc"/>
-    <p:sldId xmlns:r="http://schemas.openxmlformats.org/officeDocument/2006/relationships" id="257" r:id="R9a3b8ff7eaf74a2f"/>
-    <p:sldId xmlns:r="http://schemas.openxmlformats.org/officeDocument/2006/relationships" id="258" r:id="Rf4ee756328d2421d"/>
-    <p:sldId xmlns:r="http://schemas.openxmlformats.org/officeDocument/2006/relationships" id="259" r:id="R090a4cba7ad047fa"/>
-    <p:sldId xmlns:r="http://schemas.openxmlformats.org/officeDocument/2006/relationships" id="260" r:id="Rc8191888c336433c"/>
-    <p:sldId xmlns:r="http://schemas.openxmlformats.org/officeDocument/2006/relationships" id="261" r:id="Rd17db4b12e3a4cc7"/>
-    <p:sldId xmlns:r="http://schemas.openxmlformats.org/officeDocument/2006/relationships" id="262" r:id="R2a548046cd324e9e"/>
-    <p:sldId xmlns:r="http://schemas.openxmlformats.org/officeDocument/2006/relationships" id="263" r:id="Rb5c4161898d3434c"/>
+    <p:sldId xmlns:r="http://schemas.openxmlformats.org/officeDocument/2006/relationships" id="256" r:id="R87772b955b1e45bb"/>
+    <p:sldId xmlns:r="http://schemas.openxmlformats.org/officeDocument/2006/relationships" id="257" r:id="R55addca3b5db4702"/>
+    <p:sldId xmlns:r="http://schemas.openxmlformats.org/officeDocument/2006/relationships" id="258" r:id="R82ef83680038479b"/>
+    <p:sldId xmlns:r="http://schemas.openxmlformats.org/officeDocument/2006/relationships" id="259" r:id="Rc8c61550c29e4345"/>
+    <p:sldId xmlns:r="http://schemas.openxmlformats.org/officeDocument/2006/relationships" id="260" r:id="R3389541d59b54637"/>
+    <p:sldId xmlns:r="http://schemas.openxmlformats.org/officeDocument/2006/relationships" id="261" r:id="R38133fefcdbe4b1f"/>
+    <p:sldId xmlns:r="http://schemas.openxmlformats.org/officeDocument/2006/relationships" id="262" r:id="R2b0833d8502e4771"/>
+    <p:sldId xmlns:r="http://schemas.openxmlformats.org/officeDocument/2006/relationships" id="263" r:id="Rfc421dc3cabb4e46"/>
   </p:sldIdLst>
   <p:sldSz cx="12192000" cy="6858000"/>
   <p:notesSz cx="6858000" cy="9144000"/>
@@ -939,7 +939,7 @@
           <a:lstStyle xmlns:a="http://schemas.openxmlformats.org/drawingml/2006/main"/>
           <a:p xmlns:a="http://schemas.openxmlformats.org/drawingml/2006/main">
             <a:r>
-              <a:t>Repository URL verified public through the GitHub repository API. Godot project version and C# target checked against src/project.godot and src/HiddenWatts.csproj. Run instructions target Windows PC. Opening the editor imports assets before running the main menu.</a:t>
+              <a:t>Repository URL verified public through the GitHub repository API. Godot project version and C# target checked against src/project.godot and src/HiddenWatts.csproj. The primary play instructions use the standalone Windows x64 release with its bundled runtime. Godot and the .NET SDK are needed only for source development. The README links to the release download.</a:t>
             </a:r>
           </a:p>
         </p:txBody>
@@ -986,7 +986,7 @@
           <p:cNvPr id="3" name="Title">
             <a:extLst xmlns:a="http://schemas.openxmlformats.org/drawingml/2006/main">
               <a:ext uri="{FF2B5EF4-FFF2-40B4-BE49-F238E27FC236}">
-                <a16:creationId xmlns:a16="http://schemas.microsoft.com/office/drawing/2014/main" id="{33DAADFF-8DA0-47F6-BF3A-CCC903551099}"/>
+                <a16:creationId xmlns:a16="http://schemas.microsoft.com/office/drawing/2014/main" id="{E64B7825-54F1-47BE-B39D-9D388B876256}"/>
               </a:ext>
             </a:extLst>
           </p:cNvPr>
@@ -1215,7 +1215,7 @@
           <p:cNvPr id="2" name="Subtitle">
             <a:extLst xmlns:a="http://schemas.openxmlformats.org/drawingml/2006/main">
               <a:ext uri="{FF2B5EF4-FFF2-40B4-BE49-F238E27FC236}">
-                <a16:creationId xmlns:a16="http://schemas.microsoft.com/office/drawing/2014/main" id="{7129A641-4415-4742-A981-FB7FA0233D9D}"/>
+                <a16:creationId xmlns:a16="http://schemas.microsoft.com/office/drawing/2014/main" id="{BA84A903-944B-42EF-AA53-849465585908}"/>
               </a:ext>
             </a:extLst>
           </p:cNvPr>
@@ -1461,7 +1461,7 @@
           <p:cNvPr id="2" name="Section title">
             <a:extLst xmlns:a="http://schemas.openxmlformats.org/drawingml/2006/main">
               <a:ext uri="{FF2B5EF4-FFF2-40B4-BE49-F238E27FC236}">
-                <a16:creationId xmlns:a16="http://schemas.microsoft.com/office/drawing/2014/main" id="{C8909D43-7966-42B9-AF5B-1EE4FA5DCA96}"/>
+                <a16:creationId xmlns:a16="http://schemas.microsoft.com/office/drawing/2014/main" id="{96EAA281-A432-4B52-8F3B-17CC67DAACD0}"/>
               </a:ext>
             </a:extLst>
           </p:cNvPr>
@@ -1707,7 +1707,7 @@
           <p:cNvPr id="3" name="Title">
             <a:extLst xmlns:a="http://schemas.openxmlformats.org/drawingml/2006/main">
               <a:ext uri="{FF2B5EF4-FFF2-40B4-BE49-F238E27FC236}">
-                <a16:creationId xmlns:a16="http://schemas.microsoft.com/office/drawing/2014/main" id="{1E92BE37-1D02-4D57-81FC-A672C1AED4EE}"/>
+                <a16:creationId xmlns:a16="http://schemas.microsoft.com/office/drawing/2014/main" id="{D138B7D4-568E-4761-BB99-48325C4417B3}"/>
               </a:ext>
             </a:extLst>
           </p:cNvPr>
@@ -1936,7 +1936,7 @@
           <p:cNvPr id="2" name="Body">
             <a:extLst xmlns:a="http://schemas.openxmlformats.org/drawingml/2006/main">
               <a:ext uri="{FF2B5EF4-FFF2-40B4-BE49-F238E27FC236}">
-                <a16:creationId xmlns:a16="http://schemas.microsoft.com/office/drawing/2014/main" id="{A7035998-CA6B-4C91-AEB7-00127AB10E2A}"/>
+                <a16:creationId xmlns:a16="http://schemas.microsoft.com/office/drawing/2014/main" id="{65ABBD41-88EA-4C6C-AE03-446153E7DE6E}"/>
               </a:ext>
             </a:extLst>
           </p:cNvPr>
@@ -2182,7 +2182,7 @@
           <p:cNvPr id="4" name="Title">
             <a:extLst xmlns:a="http://schemas.openxmlformats.org/drawingml/2006/main">
               <a:ext uri="{FF2B5EF4-FFF2-40B4-BE49-F238E27FC236}">
-                <a16:creationId xmlns:a16="http://schemas.microsoft.com/office/drawing/2014/main" id="{CAFF306D-4C2E-43A9-9FFC-FF633CBE8CD2}"/>
+                <a16:creationId xmlns:a16="http://schemas.microsoft.com/office/drawing/2014/main" id="{8BA4B4FD-A9BB-4119-AEA2-EAEE8642C43A}"/>
               </a:ext>
             </a:extLst>
           </p:cNvPr>
@@ -2411,7 +2411,7 @@
           <p:cNvPr id="2" name="Left column">
             <a:extLst xmlns:a="http://schemas.openxmlformats.org/drawingml/2006/main">
               <a:ext uri="{FF2B5EF4-FFF2-40B4-BE49-F238E27FC236}">
-                <a16:creationId xmlns:a16="http://schemas.microsoft.com/office/drawing/2014/main" id="{E239E387-5BA1-4181-9414-B4FB042465B8}"/>
+                <a16:creationId xmlns:a16="http://schemas.microsoft.com/office/drawing/2014/main" id="{7D56248A-972F-4693-BEC4-6EC7EE06D335}"/>
               </a:ext>
             </a:extLst>
           </p:cNvPr>
@@ -2640,7 +2640,7 @@
           <p:cNvPr id="3" name="Right column">
             <a:extLst xmlns:a="http://schemas.openxmlformats.org/drawingml/2006/main">
               <a:ext uri="{FF2B5EF4-FFF2-40B4-BE49-F238E27FC236}">
-                <a16:creationId xmlns:a16="http://schemas.microsoft.com/office/drawing/2014/main" id="{0C9D5E35-B9F7-43A4-A27D-A8E816B66ED3}"/>
+                <a16:creationId xmlns:a16="http://schemas.microsoft.com/office/drawing/2014/main" id="{5CC3F447-20B0-495A-9412-3C246DB9BEE1}"/>
               </a:ext>
             </a:extLst>
           </p:cNvPr>
@@ -2886,7 +2886,7 @@
           <p:cNvPr id="3" name="Title">
             <a:extLst xmlns:a="http://schemas.openxmlformats.org/drawingml/2006/main">
               <a:ext uri="{FF2B5EF4-FFF2-40B4-BE49-F238E27FC236}">
-                <a16:creationId xmlns:a16="http://schemas.microsoft.com/office/drawing/2014/main" id="{BDC1C905-BB83-42DE-ABD4-45889408B3D5}"/>
+                <a16:creationId xmlns:a16="http://schemas.microsoft.com/office/drawing/2014/main" id="{A829AD02-3DF1-4459-8885-BAA0C6E31757}"/>
               </a:ext>
             </a:extLst>
           </p:cNvPr>
@@ -3115,7 +3115,7 @@
           <p:cNvPr id="2" name="Left column">
             <a:extLst xmlns:a="http://schemas.openxmlformats.org/drawingml/2006/main">
               <a:ext uri="{FF2B5EF4-FFF2-40B4-BE49-F238E27FC236}">
-                <a16:creationId xmlns:a16="http://schemas.microsoft.com/office/drawing/2014/main" id="{22CD942A-3EE8-4E6A-8931-9A051DBDCA6C}"/>
+                <a16:creationId xmlns:a16="http://schemas.microsoft.com/office/drawing/2014/main" id="{5273E3E7-467A-46E6-82E7-6200F022675F}"/>
               </a:ext>
             </a:extLst>
           </p:cNvPr>
@@ -3382,12 +3382,12 @@
   </p:cSld>
   <p:clrMap bg1="lt1" tx1="dk1" bg2="lt2" tx2="dk2" accent1="accent1" accent2="accent2" accent3="accent3" accent4="accent4" accent5="accent5" accent6="accent6" hlink="hlink" folHlink="folHlink"/>
   <p:sldLayoutIdLst>
-    <p:sldLayoutId xmlns:r="http://schemas.openxmlformats.org/officeDocument/2006/relationships" id="2147483649" r:id="R51214d6b39784674"/>
-    <p:sldLayoutId xmlns:r="http://schemas.openxmlformats.org/officeDocument/2006/relationships" id="2147483650" r:id="Recfee2fa56704e3f"/>
-    <p:sldLayoutId xmlns:r="http://schemas.openxmlformats.org/officeDocument/2006/relationships" id="2147483651" r:id="R9fc664ad87ab4f5c"/>
-    <p:sldLayoutId xmlns:r="http://schemas.openxmlformats.org/officeDocument/2006/relationships" id="2147483652" r:id="R957626cd7d13485e"/>
-    <p:sldLayoutId xmlns:r="http://schemas.openxmlformats.org/officeDocument/2006/relationships" id="2147483653" r:id="R142152d6075d415c"/>
-    <p:sldLayoutId xmlns:r="http://schemas.openxmlformats.org/officeDocument/2006/relationships" id="2147483654" r:id="R5cda4f93e4ec40d2"/>
+    <p:sldLayoutId xmlns:r="http://schemas.openxmlformats.org/officeDocument/2006/relationships" id="2147483649" r:id="Rc3f1bb6da9f648a2"/>
+    <p:sldLayoutId xmlns:r="http://schemas.openxmlformats.org/officeDocument/2006/relationships" id="2147483650" r:id="R0e862283cb364852"/>
+    <p:sldLayoutId xmlns:r="http://schemas.openxmlformats.org/officeDocument/2006/relationships" id="2147483651" r:id="Rdb9ef25e2d97438c"/>
+    <p:sldLayoutId xmlns:r="http://schemas.openxmlformats.org/officeDocument/2006/relationships" id="2147483652" r:id="R49a7eac4dfb2495f"/>
+    <p:sldLayoutId xmlns:r="http://schemas.openxmlformats.org/officeDocument/2006/relationships" id="2147483653" r:id="Ree731c08be4f461d"/>
+    <p:sldLayoutId xmlns:r="http://schemas.openxmlformats.org/officeDocument/2006/relationships" id="2147483654" r:id="R5521da537ffd4ff2"/>
   </p:sldLayoutIdLst>
   <p:txStyles>
     <p:titleStyle>
@@ -3938,7 +3938,7 @@
           <p:cNvPr id="7" name="">
             <a:extLst xmlns:a="http://schemas.openxmlformats.org/drawingml/2006/main">
               <a:ext uri="{FF2B5EF4-FFF2-40B4-BE49-F238E27FC236}">
-                <a16:creationId xmlns:a16="http://schemas.microsoft.com/office/drawing/2014/main" id="{949B2E7E-F76C-4FC8-9CEC-737F65B20ABB}"/>
+                <a16:creationId xmlns:a16="http://schemas.microsoft.com/office/drawing/2014/main" id="{7D383BCD-4723-4B7B-BCB8-6DE8CA46500D}"/>
               </a:ext>
             </a:extLst>
           </p:cNvPr>
@@ -4094,7 +4094,7 @@
           <p:cNvPr id="2" name="">
             <a:extLst xmlns:a="http://schemas.openxmlformats.org/drawingml/2006/main">
               <a:ext uri="{FF2B5EF4-FFF2-40B4-BE49-F238E27FC236}">
-                <a16:creationId xmlns:a16="http://schemas.microsoft.com/office/drawing/2014/main" id="{CE4C288D-44DA-46DE-8C97-CA0423F31640}"/>
+                <a16:creationId xmlns:a16="http://schemas.microsoft.com/office/drawing/2014/main" id="{741EB5F5-8BD1-4975-806D-6E3CB3AE0688}"/>
               </a:ext>
             </a:extLst>
           </p:cNvPr>
@@ -4250,7 +4250,7 @@
           <p:cNvPr id="3" name="">
             <a:extLst xmlns:a="http://schemas.openxmlformats.org/drawingml/2006/main">
               <a:ext uri="{FF2B5EF4-FFF2-40B4-BE49-F238E27FC236}">
-                <a16:creationId xmlns:a16="http://schemas.microsoft.com/office/drawing/2014/main" id="{DE8B3842-2393-4093-B7FC-94C303345939}"/>
+                <a16:creationId xmlns:a16="http://schemas.microsoft.com/office/drawing/2014/main" id="{281AEB5B-D3E0-472E-80CD-28B366EF98C7}"/>
               </a:ext>
             </a:extLst>
           </p:cNvPr>
@@ -4429,7 +4429,7 @@
           <p:cNvPr id="4" name="">
             <a:extLst xmlns:a="http://schemas.openxmlformats.org/drawingml/2006/main">
               <a:ext uri="{FF2B5EF4-FFF2-40B4-BE49-F238E27FC236}">
-                <a16:creationId xmlns:a16="http://schemas.microsoft.com/office/drawing/2014/main" id="{E5229F3F-BBB3-484F-A4BE-FF12CA387371}"/>
+                <a16:creationId xmlns:a16="http://schemas.microsoft.com/office/drawing/2014/main" id="{6D3858FF-4282-45AE-A281-4FB0240DB2BB}"/>
               </a:ext>
             </a:extLst>
           </p:cNvPr>
@@ -4585,7 +4585,7 @@
           <p:cNvPr id="5" name="">
             <a:extLst xmlns:a="http://schemas.openxmlformats.org/drawingml/2006/main">
               <a:ext uri="{FF2B5EF4-FFF2-40B4-BE49-F238E27FC236}">
-                <a16:creationId xmlns:a16="http://schemas.microsoft.com/office/drawing/2014/main" id="{2656FC2A-5C29-4BCD-9D3A-DE9A2ADB9C3B}"/>
+                <a16:creationId xmlns:a16="http://schemas.microsoft.com/office/drawing/2014/main" id="{3A886012-D0A1-441E-88FF-C985CF2758E6}"/>
               </a:ext>
             </a:extLst>
           </p:cNvPr>
@@ -4764,7 +4764,7 @@
           <p:cNvPr id="6" name="">
             <a:extLst xmlns:a="http://schemas.openxmlformats.org/drawingml/2006/main">
               <a:ext uri="{FF2B5EF4-FFF2-40B4-BE49-F238E27FC236}">
-                <a16:creationId xmlns:a16="http://schemas.microsoft.com/office/drawing/2014/main" id="{03B52137-3F42-4B26-9232-062A26E8B40D}"/>
+                <a16:creationId xmlns:a16="http://schemas.microsoft.com/office/drawing/2014/main" id="{48B3B1A4-4FD3-4017-98C2-02346DD1C466}"/>
               </a:ext>
             </a:extLst>
           </p:cNvPr>
@@ -4774,7 +4774,7 @@
           <p:nvPr/>
         </p:nvPicPr>
         <p:blipFill>
-          <a:blip xmlns:r="http://schemas.openxmlformats.org/officeDocument/2006/relationships" xmlns:a="http://schemas.openxmlformats.org/drawingml/2006/main" r:embed="R61f20677e6ce4ccd"/>
+          <a:blip xmlns:r="http://schemas.openxmlformats.org/officeDocument/2006/relationships" xmlns:a="http://schemas.openxmlformats.org/drawingml/2006/main" r:embed="R6aa3e059449242e4"/>
           <a:stretch xmlns:a="http://schemas.openxmlformats.org/drawingml/2006/main"/>
         </p:blipFill>
         <p:spPr>
@@ -4790,7 +4790,7 @@
     </p:spTree>
     <p:extLst>
       <p:ext uri="{BB962C8B-B14F-4D97-AF65-F5344CB8AC3E}">
-        <p14:creationId xmlns:p14="http://schemas.microsoft.com/office/powerpoint/2010/main" val="1345718107"/>
+        <p14:creationId xmlns:p14="http://schemas.microsoft.com/office/powerpoint/2010/main" val="913135595"/>
       </p:ext>
     </p:extLst>
   </p:cSld>
@@ -4821,7 +4821,7 @@
           <p:cNvPr id="7" name="">
             <a:extLst xmlns:a="http://schemas.openxmlformats.org/drawingml/2006/main">
               <a:ext uri="{FF2B5EF4-FFF2-40B4-BE49-F238E27FC236}">
-                <a16:creationId xmlns:a16="http://schemas.microsoft.com/office/drawing/2014/main" id="{6A0A9D22-E152-4BEA-A3E4-F37457FF9390}"/>
+                <a16:creationId xmlns:a16="http://schemas.microsoft.com/office/drawing/2014/main" id="{3536AD22-75AA-477C-9A7F-E99D174086C3}"/>
               </a:ext>
             </a:extLst>
           </p:cNvPr>
@@ -4977,7 +4977,7 @@
           <p:cNvPr id="2" name="">
             <a:extLst xmlns:a="http://schemas.openxmlformats.org/drawingml/2006/main">
               <a:ext uri="{FF2B5EF4-FFF2-40B4-BE49-F238E27FC236}">
-                <a16:creationId xmlns:a16="http://schemas.microsoft.com/office/drawing/2014/main" id="{0B8F6E91-2375-41B5-9FB4-E34A1C577191}"/>
+                <a16:creationId xmlns:a16="http://schemas.microsoft.com/office/drawing/2014/main" id="{7B2F3916-7EB6-41BF-808B-F0FF7DA0EDD9}"/>
               </a:ext>
             </a:extLst>
           </p:cNvPr>
@@ -5133,7 +5133,7 @@
           <p:cNvPr id="3" name="">
             <a:extLst xmlns:a="http://schemas.openxmlformats.org/drawingml/2006/main">
               <a:ext uri="{FF2B5EF4-FFF2-40B4-BE49-F238E27FC236}">
-                <a16:creationId xmlns:a16="http://schemas.microsoft.com/office/drawing/2014/main" id="{18FF6926-AE86-4520-940D-D7990CD01A2E}"/>
+                <a16:creationId xmlns:a16="http://schemas.microsoft.com/office/drawing/2014/main" id="{2033DD41-763C-4D09-9B89-0C35A3BA4780}"/>
               </a:ext>
             </a:extLst>
           </p:cNvPr>
@@ -5289,7 +5289,7 @@
           <p:cNvPr id="4" name="">
             <a:extLst xmlns:a="http://schemas.openxmlformats.org/drawingml/2006/main">
               <a:ext uri="{FF2B5EF4-FFF2-40B4-BE49-F238E27FC236}">
-                <a16:creationId xmlns:a16="http://schemas.microsoft.com/office/drawing/2014/main" id="{610D673F-8FDD-4699-8735-47BB325D407F}"/>
+                <a16:creationId xmlns:a16="http://schemas.microsoft.com/office/drawing/2014/main" id="{60F35BDB-D800-4DD2-9919-29468FCFE4C2}"/>
               </a:ext>
             </a:extLst>
           </p:cNvPr>
@@ -5445,7 +5445,7 @@
           <p:cNvPr id="5" name="">
             <a:extLst xmlns:a="http://schemas.openxmlformats.org/drawingml/2006/main">
               <a:ext uri="{FF2B5EF4-FFF2-40B4-BE49-F238E27FC236}">
-                <a16:creationId xmlns:a16="http://schemas.microsoft.com/office/drawing/2014/main" id="{4420450D-4BE1-4AC9-B4C1-4397814540AA}"/>
+                <a16:creationId xmlns:a16="http://schemas.microsoft.com/office/drawing/2014/main" id="{DA226BFF-7FBB-4C57-BCEE-B7E6BD44CD44}"/>
               </a:ext>
             </a:extLst>
           </p:cNvPr>
@@ -5455,7 +5455,7 @@
           <p:nvPr/>
         </p:nvPicPr>
         <p:blipFill>
-          <a:blip xmlns:r="http://schemas.openxmlformats.org/officeDocument/2006/relationships" xmlns:a="http://schemas.openxmlformats.org/drawingml/2006/main" r:embed="R28184a1a73e743c1"/>
+          <a:blip xmlns:r="http://schemas.openxmlformats.org/officeDocument/2006/relationships" xmlns:a="http://schemas.openxmlformats.org/drawingml/2006/main" r:embed="Rd8080fdf6e7b415e"/>
           <a:stretch xmlns:a="http://schemas.openxmlformats.org/drawingml/2006/main"/>
         </p:blipFill>
         <p:spPr>
@@ -5473,7 +5473,7 @@
           <p:cNvPr id="6" name="">
             <a:extLst xmlns:a="http://schemas.openxmlformats.org/drawingml/2006/main">
               <a:ext uri="{FF2B5EF4-FFF2-40B4-BE49-F238E27FC236}">
-                <a16:creationId xmlns:a16="http://schemas.microsoft.com/office/drawing/2014/main" id="{30148033-78CF-481B-812B-974864694E61}"/>
+                <a16:creationId xmlns:a16="http://schemas.microsoft.com/office/drawing/2014/main" id="{4699AEE5-95F7-408E-853A-E8869585B30E}"/>
               </a:ext>
             </a:extLst>
           </p:cNvPr>
@@ -5650,7 +5650,7 @@
     </p:spTree>
     <p:extLst>
       <p:ext uri="{BB962C8B-B14F-4D97-AF65-F5344CB8AC3E}">
-        <p14:creationId xmlns:p14="http://schemas.microsoft.com/office/powerpoint/2010/main" val="903911790"/>
+        <p14:creationId xmlns:p14="http://schemas.microsoft.com/office/powerpoint/2010/main" val="992685707"/>
       </p:ext>
     </p:extLst>
   </p:cSld>
@@ -5681,7 +5681,7 @@
           <p:cNvPr id="6" name="">
             <a:extLst xmlns:a="http://schemas.openxmlformats.org/drawingml/2006/main">
               <a:ext uri="{FF2B5EF4-FFF2-40B4-BE49-F238E27FC236}">
-                <a16:creationId xmlns:a16="http://schemas.microsoft.com/office/drawing/2014/main" id="{DD4A2B96-A23E-42C8-A1F9-FEB9233752DA}"/>
+                <a16:creationId xmlns:a16="http://schemas.microsoft.com/office/drawing/2014/main" id="{85CDD6CF-DE03-46E6-B7CD-71CAD5B8D5E7}"/>
               </a:ext>
             </a:extLst>
           </p:cNvPr>
@@ -5837,7 +5837,7 @@
           <p:cNvPr id="2" name="">
             <a:extLst xmlns:a="http://schemas.openxmlformats.org/drawingml/2006/main">
               <a:ext uri="{FF2B5EF4-FFF2-40B4-BE49-F238E27FC236}">
-                <a16:creationId xmlns:a16="http://schemas.microsoft.com/office/drawing/2014/main" id="{DB9EB2D5-B8F8-4569-9AA1-8436A97C27B9}"/>
+                <a16:creationId xmlns:a16="http://schemas.microsoft.com/office/drawing/2014/main" id="{CD63B7CE-ABC0-42FD-ABA8-886CBCB793CF}"/>
               </a:ext>
             </a:extLst>
           </p:cNvPr>
@@ -5993,7 +5993,7 @@
           <p:cNvPr id="3" name="">
             <a:extLst xmlns:a="http://schemas.openxmlformats.org/drawingml/2006/main">
               <a:ext uri="{FF2B5EF4-FFF2-40B4-BE49-F238E27FC236}">
-                <a16:creationId xmlns:a16="http://schemas.microsoft.com/office/drawing/2014/main" id="{2FA5F956-A9C0-4F48-9D89-55BC6911E2E6}"/>
+                <a16:creationId xmlns:a16="http://schemas.microsoft.com/office/drawing/2014/main" id="{52B0C037-750B-474C-811B-470C22E66044}"/>
               </a:ext>
             </a:extLst>
           </p:cNvPr>
@@ -6149,7 +6149,7 @@
           <p:cNvPr id="4" name="">
             <a:extLst xmlns:a="http://schemas.openxmlformats.org/drawingml/2006/main">
               <a:ext uri="{FF2B5EF4-FFF2-40B4-BE49-F238E27FC236}">
-                <a16:creationId xmlns:a16="http://schemas.microsoft.com/office/drawing/2014/main" id="{5A8B2BBC-64DD-4F77-9FAD-57AA0182440A}"/>
+                <a16:creationId xmlns:a16="http://schemas.microsoft.com/office/drawing/2014/main" id="{0C86947C-593B-4F3F-9B6F-A4490A8A1362}"/>
               </a:ext>
             </a:extLst>
           </p:cNvPr>
@@ -6305,7 +6305,7 @@
           <p:cNvPr id="5" name="">
             <a:extLst xmlns:a="http://schemas.openxmlformats.org/drawingml/2006/main">
               <a:ext uri="{FF2B5EF4-FFF2-40B4-BE49-F238E27FC236}">
-                <a16:creationId xmlns:a16="http://schemas.microsoft.com/office/drawing/2014/main" id="{B6534822-B8CA-4C7B-B31B-1F065701E42F}"/>
+                <a16:creationId xmlns:a16="http://schemas.microsoft.com/office/drawing/2014/main" id="{21E69E15-DA58-4E2A-B2D3-411B4B3C282F}"/>
               </a:ext>
             </a:extLst>
           </p:cNvPr>
@@ -6315,7 +6315,7 @@
           <p:nvPr/>
         </p:nvPicPr>
         <p:blipFill>
-          <a:blip xmlns:r="http://schemas.openxmlformats.org/officeDocument/2006/relationships" xmlns:a="http://schemas.openxmlformats.org/drawingml/2006/main" r:embed="R793641548f92440c"/>
+          <a:blip xmlns:r="http://schemas.openxmlformats.org/officeDocument/2006/relationships" xmlns:a="http://schemas.openxmlformats.org/drawingml/2006/main" r:embed="Rde2d46c187ea4ab3"/>
           <a:srcRect xmlns:a="http://schemas.openxmlformats.org/drawingml/2006/main" l="19618" t="6481" r="19618" b="6481"/>
           <a:stretch xmlns:a="http://schemas.openxmlformats.org/drawingml/2006/main"/>
         </p:blipFill>
@@ -6332,7 +6332,7 @@
     </p:spTree>
     <p:extLst>
       <p:ext uri="{BB962C8B-B14F-4D97-AF65-F5344CB8AC3E}">
-        <p14:creationId xmlns:p14="http://schemas.microsoft.com/office/powerpoint/2010/main" val="1762782744"/>
+        <p14:creationId xmlns:p14="http://schemas.microsoft.com/office/powerpoint/2010/main" val="577499230"/>
       </p:ext>
     </p:extLst>
   </p:cSld>
@@ -6363,7 +6363,7 @@
           <p:cNvPr id="6" name="">
             <a:extLst xmlns:a="http://schemas.openxmlformats.org/drawingml/2006/main">
               <a:ext uri="{FF2B5EF4-FFF2-40B4-BE49-F238E27FC236}">
-                <a16:creationId xmlns:a16="http://schemas.microsoft.com/office/drawing/2014/main" id="{BBBFE5A5-C007-4EA0-901E-99E58DD5A58A}"/>
+                <a16:creationId xmlns:a16="http://schemas.microsoft.com/office/drawing/2014/main" id="{960CB9F9-5DAB-4513-890D-6CD14D60A6E1}"/>
               </a:ext>
             </a:extLst>
           </p:cNvPr>
@@ -6519,7 +6519,7 @@
           <p:cNvPr id="2" name="">
             <a:extLst xmlns:a="http://schemas.openxmlformats.org/drawingml/2006/main">
               <a:ext uri="{FF2B5EF4-FFF2-40B4-BE49-F238E27FC236}">
-                <a16:creationId xmlns:a16="http://schemas.microsoft.com/office/drawing/2014/main" id="{27C6F1C7-DF21-4A06-9EC4-4A91ACBEBD48}"/>
+                <a16:creationId xmlns:a16="http://schemas.microsoft.com/office/drawing/2014/main" id="{FEC5E536-FD3F-4017-B581-BBA92A78E403}"/>
               </a:ext>
             </a:extLst>
           </p:cNvPr>
@@ -6675,7 +6675,7 @@
           <p:cNvPr id="3" name="">
             <a:extLst xmlns:a="http://schemas.openxmlformats.org/drawingml/2006/main">
               <a:ext uri="{FF2B5EF4-FFF2-40B4-BE49-F238E27FC236}">
-                <a16:creationId xmlns:a16="http://schemas.microsoft.com/office/drawing/2014/main" id="{71619628-AF4E-49C0-9F6F-DB88EDCE3B62}"/>
+                <a16:creationId xmlns:a16="http://schemas.microsoft.com/office/drawing/2014/main" id="{B060537A-2073-4BE3-A92F-04C31EEA824D}"/>
               </a:ext>
             </a:extLst>
           </p:cNvPr>
@@ -6831,7 +6831,7 @@
           <p:cNvPr id="4" name="">
             <a:extLst xmlns:a="http://schemas.openxmlformats.org/drawingml/2006/main">
               <a:ext uri="{FF2B5EF4-FFF2-40B4-BE49-F238E27FC236}">
-                <a16:creationId xmlns:a16="http://schemas.microsoft.com/office/drawing/2014/main" id="{2CF8B8E9-0F61-4EF6-BB1A-8C0AD0EDE300}"/>
+                <a16:creationId xmlns:a16="http://schemas.microsoft.com/office/drawing/2014/main" id="{97DB904D-4EE4-435D-8744-18D8A5E17093}"/>
               </a:ext>
             </a:extLst>
           </p:cNvPr>
@@ -6987,7 +6987,7 @@
           <p:cNvPr id="5" name="">
             <a:extLst xmlns:a="http://schemas.openxmlformats.org/drawingml/2006/main">
               <a:ext uri="{FF2B5EF4-FFF2-40B4-BE49-F238E27FC236}">
-                <a16:creationId xmlns:a16="http://schemas.microsoft.com/office/drawing/2014/main" id="{687EAE4A-CD12-4A01-999C-7D94FE38FCE1}"/>
+                <a16:creationId xmlns:a16="http://schemas.microsoft.com/office/drawing/2014/main" id="{E8C8BB8A-DC1A-4075-A81D-C6D8E33A7DD7}"/>
               </a:ext>
             </a:extLst>
           </p:cNvPr>
@@ -6997,7 +6997,7 @@
           <p:nvPr/>
         </p:nvPicPr>
         <p:blipFill>
-          <a:blip xmlns:r="http://schemas.openxmlformats.org/officeDocument/2006/relationships" xmlns:a="http://schemas.openxmlformats.org/drawingml/2006/main" r:embed="Rc8b7653e9d964fd0"/>
+          <a:blip xmlns:r="http://schemas.openxmlformats.org/officeDocument/2006/relationships" xmlns:a="http://schemas.openxmlformats.org/drawingml/2006/main" r:embed="R75d7b0efec304e12"/>
           <a:srcRect xmlns:a="http://schemas.openxmlformats.org/drawingml/2006/main" l="19618" t="6481" r="19618" b="6481"/>
           <a:stretch xmlns:a="http://schemas.openxmlformats.org/drawingml/2006/main"/>
         </p:blipFill>
@@ -7014,7 +7014,7 @@
     </p:spTree>
     <p:extLst>
       <p:ext uri="{BB962C8B-B14F-4D97-AF65-F5344CB8AC3E}">
-        <p14:creationId xmlns:p14="http://schemas.microsoft.com/office/powerpoint/2010/main" val="1451803924"/>
+        <p14:creationId xmlns:p14="http://schemas.microsoft.com/office/powerpoint/2010/main" val="2133582795"/>
       </p:ext>
     </p:extLst>
   </p:cSld>
@@ -7045,7 +7045,7 @@
           <p:cNvPr id="6" name="">
             <a:extLst xmlns:a="http://schemas.openxmlformats.org/drawingml/2006/main">
               <a:ext uri="{FF2B5EF4-FFF2-40B4-BE49-F238E27FC236}">
-                <a16:creationId xmlns:a16="http://schemas.microsoft.com/office/drawing/2014/main" id="{8FB0A08D-5CF3-464F-8FEC-A360B04057A9}"/>
+                <a16:creationId xmlns:a16="http://schemas.microsoft.com/office/drawing/2014/main" id="{9A20F115-A731-4D53-AE2B-16090076C379}"/>
               </a:ext>
             </a:extLst>
           </p:cNvPr>
@@ -7201,7 +7201,7 @@
           <p:cNvPr id="2" name="">
             <a:extLst xmlns:a="http://schemas.openxmlformats.org/drawingml/2006/main">
               <a:ext uri="{FF2B5EF4-FFF2-40B4-BE49-F238E27FC236}">
-                <a16:creationId xmlns:a16="http://schemas.microsoft.com/office/drawing/2014/main" id="{B4D990B3-F34E-4B62-A810-1831E1859FD3}"/>
+                <a16:creationId xmlns:a16="http://schemas.microsoft.com/office/drawing/2014/main" id="{076E258F-EB04-432C-8CBA-7939946C8D40}"/>
               </a:ext>
             </a:extLst>
           </p:cNvPr>
@@ -7380,7 +7380,7 @@
           <p:cNvPr id="3" name="">
             <a:extLst xmlns:a="http://schemas.openxmlformats.org/drawingml/2006/main">
               <a:ext uri="{FF2B5EF4-FFF2-40B4-BE49-F238E27FC236}">
-                <a16:creationId xmlns:a16="http://schemas.microsoft.com/office/drawing/2014/main" id="{E8D805D5-ED54-4C2A-9C31-40C2E77EA97D}"/>
+                <a16:creationId xmlns:a16="http://schemas.microsoft.com/office/drawing/2014/main" id="{AEDF78F7-B5CF-460F-A4E6-3F12D6A9A974}"/>
               </a:ext>
             </a:extLst>
           </p:cNvPr>
@@ -7559,7 +7559,7 @@
           <p:cNvPr id="4" name="">
             <a:extLst xmlns:a="http://schemas.openxmlformats.org/drawingml/2006/main">
               <a:ext uri="{FF2B5EF4-FFF2-40B4-BE49-F238E27FC236}">
-                <a16:creationId xmlns:a16="http://schemas.microsoft.com/office/drawing/2014/main" id="{77CB3772-BF48-41EC-9A7C-00B597B57500}"/>
+                <a16:creationId xmlns:a16="http://schemas.microsoft.com/office/drawing/2014/main" id="{A5CBE070-85EE-4ED7-A1E4-992FED5FCAFC}"/>
               </a:ext>
             </a:extLst>
           </p:cNvPr>
@@ -7715,7 +7715,7 @@
           <p:cNvPr id="5" name="">
             <a:extLst xmlns:a="http://schemas.openxmlformats.org/drawingml/2006/main">
               <a:ext uri="{FF2B5EF4-FFF2-40B4-BE49-F238E27FC236}">
-                <a16:creationId xmlns:a16="http://schemas.microsoft.com/office/drawing/2014/main" id="{14E5F27D-7FE9-4E01-98A0-8A51F0731FAB}"/>
+                <a16:creationId xmlns:a16="http://schemas.microsoft.com/office/drawing/2014/main" id="{7F9036E4-0F47-461B-8B97-26F78E2BDC21}"/>
               </a:ext>
             </a:extLst>
           </p:cNvPr>
@@ -7725,7 +7725,7 @@
           <p:nvPr/>
         </p:nvPicPr>
         <p:blipFill>
-          <a:blip xmlns:r="http://schemas.openxmlformats.org/officeDocument/2006/relationships" xmlns:a="http://schemas.openxmlformats.org/drawingml/2006/main" r:embed="Rf112dd6e398645d0"/>
+          <a:blip xmlns:r="http://schemas.openxmlformats.org/officeDocument/2006/relationships" xmlns:a="http://schemas.openxmlformats.org/drawingml/2006/main" r:embed="R68510fab55084813"/>
           <a:srcRect xmlns:a="http://schemas.openxmlformats.org/drawingml/2006/main" l="19618" t="6481" r="19618" b="6481"/>
           <a:stretch xmlns:a="http://schemas.openxmlformats.org/drawingml/2006/main"/>
         </p:blipFill>
@@ -7742,7 +7742,7 @@
     </p:spTree>
     <p:extLst>
       <p:ext uri="{BB962C8B-B14F-4D97-AF65-F5344CB8AC3E}">
-        <p14:creationId xmlns:p14="http://schemas.microsoft.com/office/powerpoint/2010/main" val="1783498666"/>
+        <p14:creationId xmlns:p14="http://schemas.microsoft.com/office/powerpoint/2010/main" val="1324733478"/>
       </p:ext>
     </p:extLst>
   </p:cSld>
@@ -7773,7 +7773,7 @@
           <p:cNvPr id="10" name="">
             <a:extLst xmlns:a="http://schemas.openxmlformats.org/drawingml/2006/main">
               <a:ext uri="{FF2B5EF4-FFF2-40B4-BE49-F238E27FC236}">
-                <a16:creationId xmlns:a16="http://schemas.microsoft.com/office/drawing/2014/main" id="{84AFB034-6594-4B58-90DC-9EB65F071F57}"/>
+                <a16:creationId xmlns:a16="http://schemas.microsoft.com/office/drawing/2014/main" id="{FE9D33A3-4DBF-4B2C-A328-2D9F8ED39F19}"/>
               </a:ext>
             </a:extLst>
           </p:cNvPr>
@@ -7929,7 +7929,7 @@
           <p:cNvPr id="2" name="">
             <a:extLst xmlns:a="http://schemas.openxmlformats.org/drawingml/2006/main">
               <a:ext uri="{FF2B5EF4-FFF2-40B4-BE49-F238E27FC236}">
-                <a16:creationId xmlns:a16="http://schemas.microsoft.com/office/drawing/2014/main" id="{DF905961-A75A-4898-8016-DB4A3A29EDEA}"/>
+                <a16:creationId xmlns:a16="http://schemas.microsoft.com/office/drawing/2014/main" id="{21DC23E0-563F-41A3-A5A3-E3BD4677941B}"/>
               </a:ext>
             </a:extLst>
           </p:cNvPr>
@@ -8085,7 +8085,7 @@
           <p:cNvPr id="3" name="">
             <a:extLst xmlns:a="http://schemas.openxmlformats.org/drawingml/2006/main">
               <a:ext uri="{FF2B5EF4-FFF2-40B4-BE49-F238E27FC236}">
-                <a16:creationId xmlns:a16="http://schemas.microsoft.com/office/drawing/2014/main" id="{86281183-FFB0-46B7-B11B-ED75598D4D67}"/>
+                <a16:creationId xmlns:a16="http://schemas.microsoft.com/office/drawing/2014/main" id="{A7151ECD-1641-40CE-8091-88FB31759684}"/>
               </a:ext>
             </a:extLst>
           </p:cNvPr>
@@ -8241,7 +8241,7 @@
           <p:cNvPr id="4" name="">
             <a:extLst xmlns:a="http://schemas.openxmlformats.org/drawingml/2006/main">
               <a:ext uri="{FF2B5EF4-FFF2-40B4-BE49-F238E27FC236}">
-                <a16:creationId xmlns:a16="http://schemas.microsoft.com/office/drawing/2014/main" id="{76F1189A-FE7E-40F3-B06F-9A105BE42D84}"/>
+                <a16:creationId xmlns:a16="http://schemas.microsoft.com/office/drawing/2014/main" id="{3D2FE0B8-4DB9-4504-ABC8-8485B0273882}"/>
               </a:ext>
             </a:extLst>
           </p:cNvPr>
@@ -8397,7 +8397,7 @@
           <p:cNvPr id="5" name="">
             <a:extLst xmlns:a="http://schemas.openxmlformats.org/drawingml/2006/main">
               <a:ext uri="{FF2B5EF4-FFF2-40B4-BE49-F238E27FC236}">
-                <a16:creationId xmlns:a16="http://schemas.microsoft.com/office/drawing/2014/main" id="{8B9E4215-8252-4DD2-B5B6-C23E840F97D6}"/>
+                <a16:creationId xmlns:a16="http://schemas.microsoft.com/office/drawing/2014/main" id="{C3C4ABAF-9451-4C58-B4E4-C6DE7010C6F8}"/>
               </a:ext>
             </a:extLst>
           </p:cNvPr>
@@ -8553,7 +8553,7 @@
           <p:cNvPr id="6" name="">
             <a:extLst xmlns:a="http://schemas.openxmlformats.org/drawingml/2006/main">
               <a:ext uri="{FF2B5EF4-FFF2-40B4-BE49-F238E27FC236}">
-                <a16:creationId xmlns:a16="http://schemas.microsoft.com/office/drawing/2014/main" id="{C6867539-BE16-4806-A2CA-A8CFE94991EB}"/>
+                <a16:creationId xmlns:a16="http://schemas.microsoft.com/office/drawing/2014/main" id="{3BD8C399-07D1-45F4-8273-9AD28A1C11CB}"/>
               </a:ext>
             </a:extLst>
           </p:cNvPr>
@@ -8709,7 +8709,7 @@
           <p:cNvPr id="7" name="">
             <a:extLst xmlns:a="http://schemas.openxmlformats.org/drawingml/2006/main">
               <a:ext uri="{FF2B5EF4-FFF2-40B4-BE49-F238E27FC236}">
-                <a16:creationId xmlns:a16="http://schemas.microsoft.com/office/drawing/2014/main" id="{09F445F0-8169-4541-AEF8-2197DA80CFB6}"/>
+                <a16:creationId xmlns:a16="http://schemas.microsoft.com/office/drawing/2014/main" id="{E039CAB7-D609-4B48-A894-A9802066B2B1}"/>
               </a:ext>
             </a:extLst>
           </p:cNvPr>
@@ -8865,7 +8865,7 @@
           <p:cNvPr id="8" name="">
             <a:extLst xmlns:a="http://schemas.openxmlformats.org/drawingml/2006/main">
               <a:ext uri="{FF2B5EF4-FFF2-40B4-BE49-F238E27FC236}">
-                <a16:creationId xmlns:a16="http://schemas.microsoft.com/office/drawing/2014/main" id="{FAD509F8-FACE-4969-8285-C9421F709541}"/>
+                <a16:creationId xmlns:a16="http://schemas.microsoft.com/office/drawing/2014/main" id="{62940D55-036B-4350-A697-0C6E9F610008}"/>
               </a:ext>
             </a:extLst>
           </p:cNvPr>
@@ -9021,7 +9021,7 @@
           <p:cNvPr id="9" name="">
             <a:extLst xmlns:a="http://schemas.openxmlformats.org/drawingml/2006/main">
               <a:ext uri="{FF2B5EF4-FFF2-40B4-BE49-F238E27FC236}">
-                <a16:creationId xmlns:a16="http://schemas.microsoft.com/office/drawing/2014/main" id="{D6B057E9-AE4B-4248-AF9C-8C00518DC11F}"/>
+                <a16:creationId xmlns:a16="http://schemas.microsoft.com/office/drawing/2014/main" id="{9CAC2DAF-B868-443A-9BE1-212BB7004004}"/>
               </a:ext>
             </a:extLst>
           </p:cNvPr>
@@ -9175,7 +9175,7 @@
     </p:spTree>
     <p:extLst>
       <p:ext uri="{BB962C8B-B14F-4D97-AF65-F5344CB8AC3E}">
-        <p14:creationId xmlns:p14="http://schemas.microsoft.com/office/powerpoint/2010/main" val="1311949541"/>
+        <p14:creationId xmlns:p14="http://schemas.microsoft.com/office/powerpoint/2010/main" val="1192454381"/>
       </p:ext>
     </p:extLst>
   </p:cSld>
@@ -9206,7 +9206,7 @@
           <p:cNvPr id="11" name="">
             <a:extLst xmlns:a="http://schemas.openxmlformats.org/drawingml/2006/main">
               <a:ext uri="{FF2B5EF4-FFF2-40B4-BE49-F238E27FC236}">
-                <a16:creationId xmlns:a16="http://schemas.microsoft.com/office/drawing/2014/main" id="{6BA5850C-968F-427D-9C56-410A206463C6}"/>
+                <a16:creationId xmlns:a16="http://schemas.microsoft.com/office/drawing/2014/main" id="{D1AC9840-3941-4A26-B746-DCB29DC4B41A}"/>
               </a:ext>
             </a:extLst>
           </p:cNvPr>
@@ -9362,7 +9362,7 @@
           <p:cNvPr id="2" name="">
             <a:extLst xmlns:a="http://schemas.openxmlformats.org/drawingml/2006/main">
               <a:ext uri="{FF2B5EF4-FFF2-40B4-BE49-F238E27FC236}">
-                <a16:creationId xmlns:a16="http://schemas.microsoft.com/office/drawing/2014/main" id="{FA7725EF-2200-4A63-8583-8AF61745EB3B}"/>
+                <a16:creationId xmlns:a16="http://schemas.microsoft.com/office/drawing/2014/main" id="{6F05D278-8B37-4CD5-A7C6-AC80A874365E}"/>
               </a:ext>
             </a:extLst>
           </p:cNvPr>
@@ -9518,7 +9518,7 @@
           <p:cNvPr id="3" name="">
             <a:extLst xmlns:a="http://schemas.openxmlformats.org/drawingml/2006/main">
               <a:ext uri="{FF2B5EF4-FFF2-40B4-BE49-F238E27FC236}">
-                <a16:creationId xmlns:a16="http://schemas.microsoft.com/office/drawing/2014/main" id="{0FE06797-F32D-45B2-BBD1-6C75E701C68F}"/>
+                <a16:creationId xmlns:a16="http://schemas.microsoft.com/office/drawing/2014/main" id="{2184BBFA-B5DC-4F17-94CE-5C1E5A02EB5B}"/>
               </a:ext>
             </a:extLst>
           </p:cNvPr>
@@ -9674,7 +9674,7 @@
           <p:cNvPr id="4" name="">
             <a:extLst xmlns:a="http://schemas.openxmlformats.org/drawingml/2006/main">
               <a:ext uri="{FF2B5EF4-FFF2-40B4-BE49-F238E27FC236}">
-                <a16:creationId xmlns:a16="http://schemas.microsoft.com/office/drawing/2014/main" id="{3CA2AD14-53CC-49AF-8BA7-95B5DB74B203}"/>
+                <a16:creationId xmlns:a16="http://schemas.microsoft.com/office/drawing/2014/main" id="{47130F15-3C91-4CB6-A4C4-19E7791213DC}"/>
               </a:ext>
             </a:extLst>
           </p:cNvPr>
@@ -9830,7 +9830,7 @@
           <p:cNvPr id="5" name="">
             <a:extLst xmlns:a="http://schemas.openxmlformats.org/drawingml/2006/main">
               <a:ext uri="{FF2B5EF4-FFF2-40B4-BE49-F238E27FC236}">
-                <a16:creationId xmlns:a16="http://schemas.microsoft.com/office/drawing/2014/main" id="{9465CC34-8F51-4345-9A1A-07EC0A360BFB}"/>
+                <a16:creationId xmlns:a16="http://schemas.microsoft.com/office/drawing/2014/main" id="{502ED3A6-52DD-4D74-A21F-3AA8E556B613}"/>
               </a:ext>
             </a:extLst>
           </p:cNvPr>
@@ -9986,7 +9986,7 @@
           <p:cNvPr id="6" name="">
             <a:extLst xmlns:a="http://schemas.openxmlformats.org/drawingml/2006/main">
               <a:ext uri="{FF2B5EF4-FFF2-40B4-BE49-F238E27FC236}">
-                <a16:creationId xmlns:a16="http://schemas.microsoft.com/office/drawing/2014/main" id="{EBEEE588-A71C-4550-A4A6-88AFC20E6F5B}"/>
+                <a16:creationId xmlns:a16="http://schemas.microsoft.com/office/drawing/2014/main" id="{7F7890FD-F66E-4F3F-BCC5-D89BDB1273AD}"/>
               </a:ext>
             </a:extLst>
           </p:cNvPr>
@@ -10142,7 +10142,7 @@
           <p:cNvPr id="7" name="">
             <a:extLst xmlns:a="http://schemas.openxmlformats.org/drawingml/2006/main">
               <a:ext uri="{FF2B5EF4-FFF2-40B4-BE49-F238E27FC236}">
-                <a16:creationId xmlns:a16="http://schemas.microsoft.com/office/drawing/2014/main" id="{F844B39E-0396-4327-8033-364502FFF9E8}"/>
+                <a16:creationId xmlns:a16="http://schemas.microsoft.com/office/drawing/2014/main" id="{8C4C6A8F-BD4C-45CC-873B-24AB0E86C556}"/>
               </a:ext>
             </a:extLst>
           </p:cNvPr>
@@ -10298,7 +10298,7 @@
           <p:cNvPr id="8" name="">
             <a:extLst xmlns:a="http://schemas.openxmlformats.org/drawingml/2006/main">
               <a:ext uri="{FF2B5EF4-FFF2-40B4-BE49-F238E27FC236}">
-                <a16:creationId xmlns:a16="http://schemas.microsoft.com/office/drawing/2014/main" id="{97E1A0EF-DE51-4424-9A46-0B34C53245A3}"/>
+                <a16:creationId xmlns:a16="http://schemas.microsoft.com/office/drawing/2014/main" id="{D8775DE6-0B0E-4EA0-B7AC-0B2FAEF28CA3}"/>
               </a:ext>
             </a:extLst>
           </p:cNvPr>
@@ -10454,7 +10454,7 @@
           <p:cNvPr id="9" name="">
             <a:extLst xmlns:a="http://schemas.openxmlformats.org/drawingml/2006/main">
               <a:ext uri="{FF2B5EF4-FFF2-40B4-BE49-F238E27FC236}">
-                <a16:creationId xmlns:a16="http://schemas.microsoft.com/office/drawing/2014/main" id="{1C53A5A6-E52F-4E9C-8E9B-D2D38EF0E797}"/>
+                <a16:creationId xmlns:a16="http://schemas.microsoft.com/office/drawing/2014/main" id="{62863F89-D50F-4EB7-A460-178FA54A6572}"/>
               </a:ext>
             </a:extLst>
           </p:cNvPr>
@@ -10610,7 +10610,7 @@
           <p:cNvPr id="10" name="">
             <a:extLst xmlns:a="http://schemas.openxmlformats.org/drawingml/2006/main">
               <a:ext uri="{FF2B5EF4-FFF2-40B4-BE49-F238E27FC236}">
-                <a16:creationId xmlns:a16="http://schemas.microsoft.com/office/drawing/2014/main" id="{EF2F07E1-1BC2-4087-85E1-CE4D14958940}"/>
+                <a16:creationId xmlns:a16="http://schemas.microsoft.com/office/drawing/2014/main" id="{D89CBFE2-79B6-4A06-BC67-B20C9FBC8E82}"/>
               </a:ext>
             </a:extLst>
           </p:cNvPr>
@@ -10764,7 +10764,7 @@
     </p:spTree>
     <p:extLst>
       <p:ext uri="{BB962C8B-B14F-4D97-AF65-F5344CB8AC3E}">
-        <p14:creationId xmlns:p14="http://schemas.microsoft.com/office/powerpoint/2010/main" val="1636309643"/>
+        <p14:creationId xmlns:p14="http://schemas.microsoft.com/office/powerpoint/2010/main" val="1717973470"/>
       </p:ext>
     </p:extLst>
   </p:cSld>
@@ -10795,7 +10795,7 @@
           <p:cNvPr id="8" name="">
             <a:extLst xmlns:a="http://schemas.openxmlformats.org/drawingml/2006/main">
               <a:ext uri="{FF2B5EF4-FFF2-40B4-BE49-F238E27FC236}">
-                <a16:creationId xmlns:a16="http://schemas.microsoft.com/office/drawing/2014/main" id="{86AC5738-DC00-416D-AA54-0C85E4995033}"/>
+                <a16:creationId xmlns:a16="http://schemas.microsoft.com/office/drawing/2014/main" id="{64ABE960-ABEB-4887-B015-63B03AF01588}"/>
               </a:ext>
             </a:extLst>
           </p:cNvPr>
@@ -10951,7 +10951,7 @@
           <p:cNvPr id="2" name="">
             <a:extLst xmlns:a="http://schemas.openxmlformats.org/drawingml/2006/main">
               <a:ext uri="{FF2B5EF4-FFF2-40B4-BE49-F238E27FC236}">
-                <a16:creationId xmlns:a16="http://schemas.microsoft.com/office/drawing/2014/main" id="{6563C567-D269-4807-9CDE-F0919442ED29}"/>
+                <a16:creationId xmlns:a16="http://schemas.microsoft.com/office/drawing/2014/main" id="{AE55E582-386C-4EC5-84F3-0FD992D9B589}"/>
               </a:ext>
             </a:extLst>
           </p:cNvPr>
@@ -11107,7 +11107,7 @@
           <p:cNvPr id="3" name="">
             <a:extLst xmlns:a="http://schemas.openxmlformats.org/drawingml/2006/main">
               <a:ext uri="{FF2B5EF4-FFF2-40B4-BE49-F238E27FC236}">
-                <a16:creationId xmlns:a16="http://schemas.microsoft.com/office/drawing/2014/main" id="{7F2FE56F-665D-4205-B862-5EA2A3A55C3B}"/>
+                <a16:creationId xmlns:a16="http://schemas.microsoft.com/office/drawing/2014/main" id="{2F2914D3-E9B3-47E3-B573-64609524307B}"/>
               </a:ext>
             </a:extLst>
           </p:cNvPr>
@@ -11253,7 +11253,7 @@
                 <a:ea typeface="Arial"/>
                 <a:cs typeface="Arial"/>
               </a:rPr>
-              <a:t>1. Download or clone the public repository.</a:t>
+              <a:t>1. Open Releases and download the Windows x64 ZIP.</a:t>
             </a:r>
           </a:p>
         </p:txBody>
@@ -11263,7 +11263,7 @@
           <p:cNvPr id="4" name="">
             <a:extLst xmlns:a="http://schemas.openxmlformats.org/drawingml/2006/main">
               <a:ext uri="{FF2B5EF4-FFF2-40B4-BE49-F238E27FC236}">
-                <a16:creationId xmlns:a16="http://schemas.microsoft.com/office/drawing/2014/main" id="{1106F75E-FF9B-4F19-AF8E-6CDC668C10D1}"/>
+                <a16:creationId xmlns:a16="http://schemas.microsoft.com/office/drawing/2014/main" id="{9643013C-1785-440B-BD1A-AB36EBE34314}"/>
               </a:ext>
             </a:extLst>
           </p:cNvPr>
@@ -11409,7 +11409,7 @@
                 <a:ea typeface="Arial"/>
                 <a:cs typeface="Arial"/>
               </a:rPr>
-              <a:t>2. Install Godot 4.7.2 .NET and the .NET 8 SDK.</a:t>
+              <a:t>2. Extract the whole ZIP into a folder.</a:t>
             </a:r>
           </a:p>
         </p:txBody>
@@ -11419,7 +11419,7 @@
           <p:cNvPr id="5" name="">
             <a:extLst xmlns:a="http://schemas.openxmlformats.org/drawingml/2006/main">
               <a:ext uri="{FF2B5EF4-FFF2-40B4-BE49-F238E27FC236}">
-                <a16:creationId xmlns:a16="http://schemas.microsoft.com/office/drawing/2014/main" id="{D8FB3D41-F566-4AFE-9401-96C01F8C8087}"/>
+                <a16:creationId xmlns:a16="http://schemas.microsoft.com/office/drawing/2014/main" id="{030A7BBE-8D91-4540-B379-99788903FA34}"/>
               </a:ext>
             </a:extLst>
           </p:cNvPr>
@@ -11565,7 +11565,7 @@
                 <a:ea typeface="Arial"/>
                 <a:cs typeface="Arial"/>
               </a:rPr>
-              <a:t>3. Import src/project.godot in Godot and build the C# project.</a:t>
+              <a:t>3. Launch HiddenWatts.exe and choose Begin investigation.</a:t>
             </a:r>
           </a:p>
         </p:txBody>
@@ -11575,7 +11575,7 @@
           <p:cNvPr id="6" name="">
             <a:extLst xmlns:a="http://schemas.openxmlformats.org/drawingml/2006/main">
               <a:ext uri="{FF2B5EF4-FFF2-40B4-BE49-F238E27FC236}">
-                <a16:creationId xmlns:a16="http://schemas.microsoft.com/office/drawing/2014/main" id="{785B9253-83B4-4FBD-82CA-A3067094C9AA}"/>
+                <a16:creationId xmlns:a16="http://schemas.microsoft.com/office/drawing/2014/main" id="{2E8E86BE-609F-4935-8422-5A3505C1BFB2}"/>
               </a:ext>
             </a:extLst>
           </p:cNvPr>
@@ -11721,7 +11721,7 @@
                 <a:ea typeface="Arial"/>
                 <a:cs typeface="Arial"/>
               </a:rPr>
-              <a:t>4. Press F5, then choose Begin investigation.</a:t>
+              <a:t>4. Keep the executable, PCK and data folder together.</a:t>
             </a:r>
           </a:p>
         </p:txBody>
@@ -11731,7 +11731,7 @@
           <p:cNvPr id="7" name="">
             <a:extLst xmlns:a="http://schemas.openxmlformats.org/drawingml/2006/main">
               <a:ext uri="{FF2B5EF4-FFF2-40B4-BE49-F238E27FC236}">
-                <a16:creationId xmlns:a16="http://schemas.microsoft.com/office/drawing/2014/main" id="{6A1DE878-139A-4CB1-A22F-38E1BD19BC7C}"/>
+                <a16:creationId xmlns:a16="http://schemas.microsoft.com/office/drawing/2014/main" id="{47DD91B1-DD5D-4EC8-91FD-A8EDA5032038}"/>
               </a:ext>
             </a:extLst>
           </p:cNvPr>
@@ -11877,7 +11877,7 @@
                 <a:ea typeface="Arial"/>
                 <a:cs typeface="Arial"/>
               </a:rPr>
-              <a:t>The README includes build commands, controls and a short demo walkthrough.</a:t>
+              <a:t>No Godot or .NET installation needed. The download includes the runtime.</a:t>
             </a:r>
           </a:p>
         </p:txBody>
@@ -11885,7 +11885,7 @@
     </p:spTree>
     <p:extLst>
       <p:ext uri="{BB962C8B-B14F-4D97-AF65-F5344CB8AC3E}">
-        <p14:creationId xmlns:p14="http://schemas.microsoft.com/office/powerpoint/2010/main" val="1468585455"/>
+        <p14:creationId xmlns:p14="http://schemas.microsoft.com/office/powerpoint/2010/main" val="1182762445"/>
       </p:ext>
     </p:extLst>
   </p:cSld>

</xml_diff>